<commit_message>
Sharp FDE v2 cover, imageFocus, measured stock sizes, site theme fix
- Gallery site: deck-local themes (fde-desk) no longer join the library
  theme list, which added a row of broken images to every storyline.
- Stock photos: each download is measured; a listing that serves a
  smaller preview than it claims falls through to the next candidate.
  Wikimedia renditions use the standard 1920 px step and a User-Agent.
- imageFocus on title and text-image: the same crop window in PPTX
  (explicit srcRect), native PDF and SVG/HTML.
- theme from: flatness test so a dark, muted photo is not taken for a
  screenshot.
- FDE v2: 1920 px CC0 cover cropped on the laptop screen; review round 3.
- Showcase decks re-rendered and re-checked in PowerPoint; calibration
  corpus re-run (all pages 90.0 %, generated decks 87.4 %), docs updated.

Co-Authored-By: Claude Opus 5.5 <noreply@anthropic.com>
</commit_message>
<xml_diff>
--- a/docs/showcase/fde-engineer/en-v2/fde-engineer-en-v2.pptx
+++ b/docs/showcase/fde-engineer/en-v2/fde-engineer-en-v2.pptx
@@ -1025,7 +1025,7 @@
           <a:p>
             <a:r>
               <a:rPr lang="en-US" dirty="0"/>
-              <a:t>- Photo: Current Setup — Yutaka Tsutano — Openverse · Flickr — CC BY 2.0 — https://www.flickr.com/photos/23208360@N07/4532962327</a:t>
+              <a:t>- Photo: Two Loves (Unsplash) — Ehud Neuhaus paramir — Wikimedia Commons — CC0 — https://commons.wikimedia.org/wiki/File:Two_Loves_(Unsplash).jpg</a:t>
             </a:r>
             <a:endParaRPr lang="en-US" dirty="0"/>
           </a:p>
@@ -2710,7 +2710,7 @@
       </p:sp>
       <p:pic>
         <p:nvPicPr>
-          <p:cNvPr id="2" name="Image 0" descr="An engineer's desk with several monitors showing code and a laptop">    </p:cNvPr>
+          <p:cNvPr id="2" name="Image 0" descr="A laptop screen showing code, seen close up on a desk">    </p:cNvPr>
           <p:cNvPicPr>
             <a:picLocks noChangeAspect="1"/>
           </p:cNvPicPr>
@@ -2718,7 +2718,7 @@
         </p:nvPicPr>
         <p:blipFill>
           <a:blip r:embed="rId1"/>
-          <a:srcRect l="32200" r="32200" t="0" b="0"/>
+          <a:srcRect l="0" r="64390" t="0" b="0"/>
           <a:stretch/>
         </p:blipFill>
         <p:spPr>
@@ -2789,7 +2789,7 @@
                 <a:ea typeface="Arial" pitchFamily="34" charset="-122"/>
                 <a:cs typeface="Arial" pitchFamily="34" charset="-120"/>
               </a:rPr>
-              <a:t>Photo: Yutaka Tsutano / Openverse · Flickr, CC BY 2.0</a:t>
+              <a:t>Photo: Ehud Neuhaus paramir / Wikimedia Commons, CC0</a:t>
             </a:r>
             <a:endParaRPr lang="en-US" sz="800" dirty="0" kern="400000">
               <a:solidFill>

</xml_diff>